<commit_message>
decks: Lesson 4 Introduction Paragraph, shared sample essay
All 23 of Brian's slides (review quiz, general-to-specific warm-ups, four
intro styles from the sample essay) plus a current editor screenshot on
the Introduction Paragraph step. "Bored in the USA" now lives in one file
for Lessons 4 to 7.

Co-Authored-By: Claude Opus 5.5 <noreply@anthropic.com>
Claude-Session: https://claude.ai/code/session_01UdRZiPuGfgyCyhqFn7imqw
</commit_message>
<xml_diff>
--- a/docs/decks/thesis-driven-essay/lesson-2-pre-writing.pptx
+++ b/docs/decks/thesis-driven-essay/lesson-2-pre-writing.pptx
@@ -14366,7 +14366,7 @@
               <a:buNone/>
             </a:pPr>
             <a:r>
-              <a:rPr lang="en-US" sz="1900" dirty="0">
+              <a:rPr lang="en-US" sz="1800" dirty="0">
                 <a:solidFill>
                   <a:srgbClr val="3C3828"/>
                 </a:solidFill>
@@ -14383,7 +14383,7 @@
               <a:buNone/>
             </a:pPr>
             <a:r>
-              <a:rPr lang="en-US" sz="1900" dirty="0">
+              <a:rPr lang="en-US" sz="1800" dirty="0">
                 <a:solidFill>
                   <a:srgbClr val="3C3828"/>
                 </a:solidFill>
@@ -14403,7 +14403,7 @@
               <a:buNone/>
             </a:pPr>
             <a:r>
-              <a:rPr lang="en-US" sz="1900" dirty="0">
+              <a:rPr lang="en-US" sz="1800" dirty="0">
                 <a:solidFill>
                   <a:srgbClr val="3C3828"/>
                 </a:solidFill>
@@ -14420,7 +14420,7 @@
               <a:buNone/>
             </a:pPr>
             <a:r>
-              <a:rPr lang="en-US" sz="1900" dirty="0">
+              <a:rPr lang="en-US" sz="1800" dirty="0">
                 <a:solidFill>
                   <a:srgbClr val="3C3828"/>
                 </a:solidFill>
@@ -14433,7 +14433,7 @@
               </a:rPr>
               <a:t>an introduction, thesis statement, body paragraphs, and a conclusion.</a:t>
             </a:r>
-            <a:endParaRPr lang="en-US" sz="1900" dirty="0"/>
+            <a:endParaRPr lang="en-US" sz="1800" dirty="0"/>
           </a:p>
         </p:txBody>
       </p:sp>

</xml_diff>